<commit_message>
Update presentation assets and refresh signatures
</commit_message>
<xml_diff>
--- a/Documentation/Presentations/RAG-LCC_Overview_Diagram.pptx
+++ b/Documentation/Presentations/RAG-LCC_Overview_Diagram.pptx
@@ -304,7 +304,7 @@
           <a:p>
             <a:fld id="{5BCAD085-E8A6-8845-BD4E-CB4CCA059FC4}" type="datetimeFigureOut">
               <a:rPr lang="en-US" smtClean="0"/>
-              <a:t>9/23/2026</a:t>
+              <a:t>9/24/2026</a:t>
             </a:fld>
             <a:endParaRPr lang="en-US"/>
           </a:p>
@@ -472,7 +472,7 @@
           <a:p>
             <a:fld id="{5BCAD085-E8A6-8845-BD4E-CB4CCA059FC4}" type="datetimeFigureOut">
               <a:rPr lang="en-US" smtClean="0"/>
-              <a:t>9/23/2026</a:t>
+              <a:t>9/24/2026</a:t>
             </a:fld>
             <a:endParaRPr lang="en-US"/>
           </a:p>
@@ -650,7 +650,7 @@
           <a:p>
             <a:fld id="{5BCAD085-E8A6-8845-BD4E-CB4CCA059FC4}" type="datetimeFigureOut">
               <a:rPr lang="en-US" smtClean="0"/>
-              <a:t>9/23/2026</a:t>
+              <a:t>9/24/2026</a:t>
             </a:fld>
             <a:endParaRPr lang="en-US"/>
           </a:p>
@@ -818,7 +818,7 @@
           <a:p>
             <a:fld id="{5BCAD085-E8A6-8845-BD4E-CB4CCA059FC4}" type="datetimeFigureOut">
               <a:rPr lang="en-US" smtClean="0"/>
-              <a:t>9/23/2026</a:t>
+              <a:t>9/24/2026</a:t>
             </a:fld>
             <a:endParaRPr lang="en-US"/>
           </a:p>
@@ -1063,7 +1063,7 @@
           <a:p>
             <a:fld id="{5BCAD085-E8A6-8845-BD4E-CB4CCA059FC4}" type="datetimeFigureOut">
               <a:rPr lang="en-US" smtClean="0"/>
-              <a:t>9/23/2026</a:t>
+              <a:t>9/24/2026</a:t>
             </a:fld>
             <a:endParaRPr lang="en-US"/>
           </a:p>
@@ -1348,7 +1348,7 @@
           <a:p>
             <a:fld id="{5BCAD085-E8A6-8845-BD4E-CB4CCA059FC4}" type="datetimeFigureOut">
               <a:rPr lang="en-US" smtClean="0"/>
-              <a:t>9/23/2026</a:t>
+              <a:t>9/24/2026</a:t>
             </a:fld>
             <a:endParaRPr lang="en-US"/>
           </a:p>
@@ -1767,7 +1767,7 @@
           <a:p>
             <a:fld id="{5BCAD085-E8A6-8845-BD4E-CB4CCA059FC4}" type="datetimeFigureOut">
               <a:rPr lang="en-US" smtClean="0"/>
-              <a:t>9/23/2026</a:t>
+              <a:t>9/24/2026</a:t>
             </a:fld>
             <a:endParaRPr lang="en-US"/>
           </a:p>
@@ -1884,7 +1884,7 @@
           <a:p>
             <a:fld id="{5BCAD085-E8A6-8845-BD4E-CB4CCA059FC4}" type="datetimeFigureOut">
               <a:rPr lang="en-US" smtClean="0"/>
-              <a:t>9/23/2026</a:t>
+              <a:t>9/24/2026</a:t>
             </a:fld>
             <a:endParaRPr lang="en-US"/>
           </a:p>
@@ -1979,7 +1979,7 @@
           <a:p>
             <a:fld id="{5BCAD085-E8A6-8845-BD4E-CB4CCA059FC4}" type="datetimeFigureOut">
               <a:rPr lang="en-US" smtClean="0"/>
-              <a:t>9/23/2026</a:t>
+              <a:t>9/24/2026</a:t>
             </a:fld>
             <a:endParaRPr lang="en-US"/>
           </a:p>
@@ -2254,7 +2254,7 @@
           <a:p>
             <a:fld id="{5BCAD085-E8A6-8845-BD4E-CB4CCA059FC4}" type="datetimeFigureOut">
               <a:rPr lang="en-US" smtClean="0"/>
-              <a:t>9/23/2026</a:t>
+              <a:t>9/24/2026</a:t>
             </a:fld>
             <a:endParaRPr lang="en-US"/>
           </a:p>
@@ -2506,7 +2506,7 @@
           <a:p>
             <a:fld id="{5BCAD085-E8A6-8845-BD4E-CB4CCA059FC4}" type="datetimeFigureOut">
               <a:rPr lang="en-US" smtClean="0"/>
-              <a:t>9/23/2026</a:t>
+              <a:t>9/24/2026</a:t>
             </a:fld>
             <a:endParaRPr lang="en-US"/>
           </a:p>
@@ -2717,7 +2717,7 @@
           <a:p>
             <a:fld id="{5BCAD085-E8A6-8845-BD4E-CB4CCA059FC4}" type="datetimeFigureOut">
               <a:rPr lang="en-US" smtClean="0"/>
-              <a:t>9/23/2026</a:t>
+              <a:t>9/24/2026</a:t>
             </a:fld>
             <a:endParaRPr lang="en-US"/>
           </a:p>
@@ -4503,6 +4503,51 @@
           <a:xfrm>
             <a:off x="5367152" y="6107094"/>
             <a:ext cx="1188720" cy="0"/>
+          </a:xfrm>
+          <a:prstGeom prst="line">
+            <a:avLst/>
+          </a:prstGeom>
+          <a:ln w="20320">
+            <a:solidFill>
+              <a:srgbClr val="70604A"/>
+            </a:solidFill>
+          </a:ln>
+        </p:spPr>
+        <p:style>
+          <a:lnRef idx="2">
+            <a:schemeClr val="accent1"/>
+          </a:lnRef>
+          <a:fillRef idx="0">
+            <a:schemeClr val="accent1"/>
+          </a:fillRef>
+          <a:effectRef idx="1">
+            <a:schemeClr val="accent1"/>
+          </a:effectRef>
+          <a:fontRef idx="minor">
+            <a:schemeClr val="tx1"/>
+          </a:fontRef>
+        </p:style>
+      </p:cxnSp>
+      <p:cxnSp>
+        <p:nvCxnSpPr>
+          <p:cNvPr id="16" name="Connector 9">
+            <a:extLst>
+              <a:ext uri="{FF2B5EF4-FFF2-40B4-BE49-F238E27FC236}">
+                <a16:creationId xmlns:a16="http://schemas.microsoft.com/office/drawing/2014/main" id="{976D5BEE-9261-46E0-9207-5CAA64435DD3}"/>
+              </a:ext>
+            </a:extLst>
+          </p:cNvPr>
+          <p:cNvCxnSpPr>
+            <a:cxnSpLocks/>
+            <a:stCxn id="3" idx="1"/>
+            <a:endCxn id="8" idx="3"/>
+          </p:cNvCxnSpPr>
+          <p:nvPr/>
+        </p:nvCxnSpPr>
+        <p:spPr>
+          <a:xfrm flipH="1">
+            <a:off x="2300973" y="1463708"/>
+            <a:ext cx="818948" cy="2043228"/>
           </a:xfrm>
           <a:prstGeom prst="line">
             <a:avLst/>

</xml_diff>